<commit_message>
presentation diagonals and bootstrapping and drippy script set
</commit_message>
<xml_diff>
--- a/Presentations/22April_DiagonalsBootstrapping.pptx
+++ b/Presentations/22April_DiagonalsBootstrapping.pptx
@@ -6,7 +6,12 @@
   </p:sldMasterIdLst>
   <p:sldIdLst>
     <p:sldId id="256" r:id="rId2"/>
-    <p:sldId id="257" r:id="rId3"/>
+    <p:sldId id="258" r:id="rId3"/>
+    <p:sldId id="257" r:id="rId4"/>
+    <p:sldId id="259" r:id="rId5"/>
+    <p:sldId id="262" r:id="rId6"/>
+    <p:sldId id="260" r:id="rId7"/>
+    <p:sldId id="261" r:id="rId8"/>
   </p:sldIdLst>
   <p:sldSz cx="12192000" cy="6858000"/>
   <p:notesSz cx="6858000" cy="9144000"/>
@@ -106,6 +111,90 @@
     </a:lvl9pPr>
   </p:defaultTextStyle>
 </p:presentation>
+</file>
+
+<file path=ppt/ink/ink1.xml><?xml version="1.0" encoding="utf-8"?>
+<inkml:ink xmlns:inkml="http://www.w3.org/2003/InkML">
+  <inkml:definitions>
+    <inkml:context xml:id="ctx0">
+      <inkml:inkSource xml:id="inkSrc0">
+        <inkml:traceFormat>
+          <inkml:channel name="X" type="integer" min="-2.14748E9" max="2.14748E9" units="cm"/>
+          <inkml:channel name="Y" type="integer" min="-2.14748E9" max="2.14748E9" units="cm"/>
+          <inkml:channel name="F" type="integer" max="32767" units="dev"/>
+        </inkml:traceFormat>
+        <inkml:channelProperties>
+          <inkml:channelProperty channel="X" name="resolution" value="1000" units="1/cm"/>
+          <inkml:channelProperty channel="Y" name="resolution" value="1000" units="1/cm"/>
+          <inkml:channelProperty channel="F" name="resolution" value="0" units="1/dev"/>
+        </inkml:channelProperties>
+      </inkml:inkSource>
+      <inkml:timestamp xml:id="ts0" timeString="2026-04-22T13:58:56.349"/>
+    </inkml:context>
+    <inkml:brush xml:id="br0">
+      <inkml:brushProperty name="width" value="0.035" units="cm"/>
+      <inkml:brushProperty name="height" value="0.035" units="cm"/>
+      <inkml:brushProperty name="color" value="#FF0066"/>
+    </inkml:brush>
+  </inkml:definitions>
+  <inkml:trace contextRef="#ctx0" brushRef="#br0">2594 389 24575,'-9'10'0,"-5"4"0,-5 4 0,1-1 0,5-2 0,5-4 0,1-3 0,-2 1 0,-3 1 0,-1 3 0,2-1 0,2-2 0,2-4 0,2-2 0,0 0 0,-1 2 0,-3 2 0,-4 5 0,-1-1 0,1-1 0,1-1 0,5-5 0,-1 0 0,4 0 0,-1-2 0,0 4 0,0-1 0,-4 2 0,0 1 0,-1 0 0,1-2 0,0 1 0,0-1 0,0 1 0,-2 0 0,1 0 0,-1-1 0,-1 0 0,-1 0 0,0 2 0,1-1 0,2 0 0,0 1 0,-1-2 0,2 1 0,1-1 0,-1 0 0,-1 1 0,0-1 0,0 0 0,-1 1 0,2-2 0,-1 3 0,-2 1 0,-2 1 0,-3 3 0,-1 0 0,0-2 0,2-1 0,3-3 0,4 0 0,-1-1 0,2 1 0,-3 1 0,-1 1 0,1 0 0,-2-1 0,3 0 0,1-2 0,2 0 0,0-2 0,0 1 0,1-1 0,-1 1 0,-1 3 0,-1 1 0,0 0 0,-1-1 0,2 0 0,-1 0 0,0 1 0,1 2 0,0-1 0,0-1 0,1-2 0,1-1 0,-1 2 0,-1 1 0,-3 2 0,0 2 0,-2 0 0,1 2 0,0 1 0,0 1 0,-1 3 0,0-1 0,1 0 0,-1-2 0,1-2 0,1-2 0,-1 2 0,-1 3 0,-1 4 0,-3 3 0,-1 2 0,-1 0 0,0 0 0,2 0 0,0-3 0,2-2 0,2-3 0,1 0 0,0-1 0,-2 2 0,1-3 0,1-1 0,-3 2 0,-1 0 0,-1 3 0,2-2 0,3-2 0,2-3 0,0-1 0,-1-1 0,-1 3 0,0 0 0,-2 2 0,-1 1 0,1 0 0,1-1 0,-1-2 0,-1 2 0,-1-1 0,-1 2 0,2-1 0,0 0 0,-1 2 0,-1-1 0,0 2 0,-1-1 0,1 1 0,-1 2 0,0-2 0,2-2 0,1-3 0,1-2 0,2 0 0,-4 2 0,0 0 0,-1 0 0,-1 2 0,0-1 0,-1-1 0,-2 1 0,3-3 0,-2 1 0,0-1 0,-1 1 0,1 0 0,2-2 0,4-2 0,2-3 0,-2-1 0,-1 0 0,-1-1 0,2 1 0,1-1 0,-1 0 0,-4-1 0,-5 3 0,-3 2 0,-2 0 0,2-1 0,0-1 0,4-4 0,4-1 0,2-1 0,2-2 0,1 0 0,-2 0 0,1 0 0,-3 0 0,0 0 0,1 0 0,0 0 0,4 0 0,0 0 0,2 0 0,0 0 0,1 0 0,0 0 0,0 0 0,1 0 0,-1-1 0,2-1 0,2-4 0,-1-4 0,-1-2 0,0-3 0,-2-1 0,0-3 0,1 1 0,1 3 0,2 1 0,2 4 0,0 0 0,-2-2 0,2-1 0,-2 0 0,1 1 0,0 0 0,1-2 0,0 1 0,0-2 0,1 1 0,0 2 0,2-4 0,-1 0 0,-1 0 0,0-2 0,0 1 0,2-1 0,0 2 0,0 1 0,0 1 0,0 2 0,0-3 0,0 0 0,0 1 0,0 0 0,0 1 0,0 0 0,0 3 0,0 0 0,2 0 0,0-4 0,1-5 0,2 2 0,0 1 0,0 4 0,0 0 0,2-5 0,1-3 0,3-1 0,0 4 0,0 4 0,-1 3 0,1 2 0,-2 1 0,2-1 0,-1 0 0,0-1 0,2 1 0,-2 2 0,2-1 0,-1-1 0,0 0 0,-2 1 0,-2 2 0,-2 2 0,-2 1 0,2-2 0,-1 1 0,1 0 0,1-2 0,0 0 0,2 0 0,1-3 0,1 1 0,-2 0 0,0 2 0,-1 0 0,0 1 0,-1-2 0,1 0 0,1-1 0,2-1 0,1 0 0,-1 1 0,-2-1 0,0 1 0,-1-1 0,0 1 0,-2 1 0,0 3 0,-2-1 0,1 1 0,0 0 0,0-1 0,2-1 0,5-4 0,3-3 0,0-1 0,0 0 0,-3 4 0,-1 0 0,1-1 0,2 0 0,0-2 0,1 1 0,0 1 0,-1 0 0,0-1 0,-1 1 0,0 0 0,0 0 0,1-1 0,1 1 0,0-1 0,0 1 0,-1 0 0,1 0 0,0 2 0,0-1 0,-1 1 0,1-1 0,0-1 0,-2 1 0,0 0 0,0 2 0,0-2 0,2-1 0,-1-2 0,-1-2 0,-2 2 0,1 0 0,-2 1 0,0 0 0,0 0 0,0 1 0,0 0 0,1-1 0,0-1 0,-1 3 0,-1-1 0,-1 1 0,1 1 0,0-1 0,0 1 0,0-1 0,0 1 0,-1-1 0,2 0 0,1 1 0,1-1 0,1 1 0,0-1 0,0-2 0,1 1 0,-1 0 0,-2 3 0,-2 1 0,-1-1 0,-2 0 0,1-1 0,1 1 0,1-1 0,2-2 0,1 1 0,0-1 0,1 0 0,0-1 0,2-1 0,4-1 0,0-1 0,1 1 0,-3 1 0,-1 1 0,-1 2 0,-1 1 0,-1 0 0,0-1 0,0 0 0,0-1 0,0 1 0,0-2 0,-1-1 0,2-2 0,1-1 0,0 1 0,0 1 0,0 2 0,0 1 0,0-1 0,-1 2 0,1 0 0,0-1 0,-1 1 0,1-1 0,0 1 0,0 2 0,-1-2 0,3 0 0,0 0 0,1 0 0,-2 1 0,-1-1 0,-2 1 0,0-1 0,-2 2 0,0-1 0,2-1 0,-1 1 0,0-1 0,1 0 0,0 1 0,-1 0 0,0-1 0,-1 0 0,1 1 0,-1-1 0,1 0 0,0-1 0,0 0 0,0 1 0,-2 0 0,0 1 0,-1 1 0,1 0 0,0-2 0,1 0 0,0-1 0,1 0 0,0-1 0,1-1 0,1 0 0,1-1 0,0 0 0,-1 2 0,-1 0 0,-1-1 0,3 0 0,3-2 0,-1 1 0,0 2 0,-3 1 0,3-1 0,4 0 0,2-2 0,1 1 0,-1 3 0,-1-3 0,3 1 0,3-4 0,4-1 0,2 1 0,-3 2 0,-4 2 0,-6 4 0,-4 2 0,-3 3 0,-1 1 0,0 1 0,-1 0 0,2 0 0,1 0 0,-1 0 0,3 0 0,1 0 0,-1 0 0,0 0 0,-3 0 0,-4 1 0,-2 0 0,-3 2 0,-2 1 0,1 1 0,0 2 0,0 0 0,0 0 0,0-2 0,-1 1 0,0 1 0,1 2 0,-1 6 0,0 3 0,0 0 0,-1-1 0,-1-5 0,0-2 0,0-3 0,0-1 0,0 1 0,0 3 0,0 3 0,0 1 0,-1-2 0,-1-5 0,0-3 0,-2 1 0,0 1 0,-1 1 0,0 0 0,-1 1 0,-1 2 0,0-1 0,0-1 0,1-1 0,0-2 0,-2 2 0,-2 0 0,-3 1 0,1-1 0,4-3 0,4-2 0</inkml:trace>
+</inkml:ink>
+</file>
+
+<file path=ppt/ink/ink2.xml><?xml version="1.0" encoding="utf-8"?>
+<inkml:ink xmlns:inkml="http://www.w3.org/2003/InkML">
+  <inkml:definitions>
+    <inkml:context xml:id="ctx0">
+      <inkml:inkSource xml:id="inkSrc0">
+        <inkml:traceFormat>
+          <inkml:channel name="X" type="integer" min="-2.14748E9" max="2.14748E9" units="cm"/>
+          <inkml:channel name="Y" type="integer" min="-2.14748E9" max="2.14748E9" units="cm"/>
+          <inkml:channel name="F" type="integer" max="32767" units="dev"/>
+        </inkml:traceFormat>
+        <inkml:channelProperties>
+          <inkml:channelProperty channel="X" name="resolution" value="1000" units="1/cm"/>
+          <inkml:channelProperty channel="Y" name="resolution" value="1000" units="1/cm"/>
+          <inkml:channelProperty channel="F" name="resolution" value="0" units="1/dev"/>
+        </inkml:channelProperties>
+      </inkml:inkSource>
+      <inkml:timestamp xml:id="ts0" timeString="2026-04-22T14:53:47.645"/>
+    </inkml:context>
+    <inkml:brush xml:id="br0">
+      <inkml:brushProperty name="width" value="0.035" units="cm"/>
+      <inkml:brushProperty name="height" value="0.035" units="cm"/>
+      <inkml:brushProperty name="color" value="#FF0066"/>
+    </inkml:brush>
+  </inkml:definitions>
+  <inkml:trace contextRef="#ctx0" brushRef="#br0">3310 913 24575,'-4'1'0,"-1"4"0,-5 5 0,-2 6 0,-5 1 0,1 1 0,4-4 0,2-3 0,1 1 0,0-1 0,-4 5 0,-5 3 0,-4 3 0,-4 5 0,-2 4 0,4-1 0,5-5 0,6-5 0,-2-3 0,-7 4 0,-7 9 0,-8 7 0,-3 3 0,0-1 0,5-7 0,5-5 0,2-2 0,-8 1 0,-11 8 0,-10 8 0,0 5 0,8-4 0,12-9 0,12-9 0,8-9 0,2-1 0,-4 1 0,-13 9 0,-18 12 0,-12 13 0,-3 5 0,2 0 0,5-3 0,6-4 0,1-3 0,4-2 0,3-2 0,0 0 0,0 2 0,-2 3 0,-3 1 0,0 1 0,3-1 0,3-2 0,3-2 0,-1 1 0,-2-3 0,2 0 0,1-4 0,3-3 0,2 2 0,-3 2 0,0 0 0,1-1 0,2-3 0,1-1 0,0 1 0,0 0 0,-2 0 0,-4 3 0,-4 3 0,-3-2 0,0-3 0,2-8 0,-2-6 0,-1-3 0,0-5 0,-1-3 0,5 0 0,0-3 0,-3 1 0,-1-3 0,0-1 0,4-2 0,8-2 0,7 0 0,4 0 0,-1 0 0,-3-3 0,-5-9 0,0-6 0,6-5 0,5-3 0,10-1 0,3-3 0,2-6 0,2-1 0,0-3 0,4 1 0,2 4 0,0 0 0,0 3 0,0 3 0,0 3 0,0 3 0,0 2 0,3 3 0,2 1 0,2-1 0,5-2 0,3-8 0,4-6 0,3 2 0,-2 3 0,0 5 0,1-1 0,4-5 0,6-4 0,0-1 0,0 4 0,-7 6 0,-7 8 0,-3 7 0,1-4 0,5-10 0,12-14 0,7-11 0,-1 4 0,-6 9 0,-10 14 0,-7 6 0,0-6 0,2-10 0,10-13 0,10-10 0,3 2 0,-2 8 0,-10 15 0,-11 12 0,-5 4 0,-2-3 0,2-5 0,6-10 0,5-5 0,2 4 0,-4 6 0,-9 10 0,-3 7 0,-3 0 0,3-2 0,4-5 0,4-5 0,1-2 0,3-2 0,9-6 0,11-7 0,15-11 0,9-10 0,-4 2 0,-8 7 0,-13 15 0,-10 7 0,1 0 0,5-6 0,4-5 0,1 2 0,-6 4 0,-4 2 0,0-2 0,3-4 0,1 0 0,-4 2 0,-5 6 0,-9 5 0,-3 5 0,-5 6 0,-3 3 0,1 2 0,1-5 0,6-8 0,3-4 0,3 0 0,0 3 0,-1 3 0,-2 0 0,0 1 0,0-2 0,1-2 0,3-3 0,-1-1 0,0 3 0,0 1 0,-2 5 0,-1 3 0,0 1 0,17-8 0,29-16 0,-19 12 0,4 0 0,3-2 0,1 0 0,35-18 0,-29 19 0,-28 13 0,-12 8 0,-6 1 0,0-2 0,2-1 0,1-2 0,2 1 0,0-4 0,1-2 0,2-3 0,-3 0 0,-2 2 0,-1 5 0,1 3 0,5 3 0,6 2 0,1 1 0,-1 2 0,-4 0 0,-2 0 0,-3 0 0,-1 0 0,4 0 0,11-2 0,17-1 0,9-1 0,-1 1 0,-12 2 0,-15 1 0,-12 0 0,-5 1 0,-3 4 0,0 3 0,0 1 0,1 2 0,1 0 0,3 1 0,-2 0 0,-1-1 0,-3-1 0,-1-2 0,-1-1 0,-1 2 0,3 3 0,1 3 0,-1-1 0,0-1 0,-2 0 0,1 1 0,0 2 0,-1 2 0,0 4 0,-2 1 0,-1 0 0,-3 0 0,0-4 0,0 1 0,0-4 0,0 1 0,0-3 0,0 0 0,0 2 0,0-1 0,0 1 0,0-1 0,0-1 0,0 0 0,0 0 0,-2 0 0,0-1 0,0 1 0,-3 0 0,0 4 0,0 1 0,-1-1 0,2-1 0,-1-2 0,-3-3 0,-2 0 0,-2 3 0,0 1 0,2-4 0,4-2 0,0-2 0,0 0 0,-2 1 0,-1 0 0,2 1 0,0-3 0,2-1 0,2-4 0,1 0 0</inkml:trace>
+</inkml:ink>
+</file>
+
+<file path=ppt/ink/ink3.xml><?xml version="1.0" encoding="utf-8"?>
+<inkml:ink xmlns:inkml="http://www.w3.org/2003/InkML">
+  <inkml:definitions>
+    <inkml:context xml:id="ctx0">
+      <inkml:inkSource xml:id="inkSrc0">
+        <inkml:traceFormat>
+          <inkml:channel name="X" type="integer" min="-2.14748E9" max="2.14748E9" units="cm"/>
+          <inkml:channel name="Y" type="integer" min="-2.14748E9" max="2.14748E9" units="cm"/>
+          <inkml:channel name="F" type="integer" max="32767" units="dev"/>
+        </inkml:traceFormat>
+        <inkml:channelProperties>
+          <inkml:channelProperty channel="X" name="resolution" value="1000" units="1/cm"/>
+          <inkml:channelProperty channel="Y" name="resolution" value="1000" units="1/cm"/>
+          <inkml:channelProperty channel="F" name="resolution" value="0" units="1/dev"/>
+        </inkml:channelProperties>
+      </inkml:inkSource>
+      <inkml:timestamp xml:id="ts0" timeString="2026-04-22T14:54:04.728"/>
+    </inkml:context>
+    <inkml:brush xml:id="br0">
+      <inkml:brushProperty name="width" value="0.035" units="cm"/>
+      <inkml:brushProperty name="height" value="0.035" units="cm"/>
+      <inkml:brushProperty name="color" value="#FF0066"/>
+    </inkml:brush>
+  </inkml:definitions>
+  <inkml:trace contextRef="#ctx0" brushRef="#br0">45 522 24575,'15'0'0,"10"6"0,17 9 0,7 9 0,3 4 0,-11-3 0,-6 1 0,11 15 0,19 22 0,-24-24 0,0 2 0,3 1 0,-2 0 0,-4-6 0,-3-2 0,19 17 0,-15-12 0,2-1 0,7 9 0,12 17 0,-26-27 0,-1 2 0,25 37 0,-11-7 0,-12-10 0,-5-5 0,0 2 0,4 10 0,-1 12 0,3 3 0,-2 1 0,-1-7 0,0-12 0,-3-11 0,1-9 0,0 1 0,10 3 0,18 10 0,16 7 0,-35-34 0,1-1 0,32 21 0,-17-16 0,-15-14 0,-7-8 0,-5-7 0,3-4 0,8-1 0,18 0 0,22 0 0,13 0 0,3-4 0,-10-7 0,-16-9 0,-15-5 0,-11-1 0,-10 3 0,-8 2 0,-7 1 0,-6 0 0,-5 3 0,-2 2 0,-1 1 0,-3 2 0,0-5 0,-1-5 0,-1-2 0,0-2 0,0 1 0,0-8 0,0-14 0,-11-13 0,-11-12 0,-10 2 0,-8 10 0,2 5 0,-8-4 0,-14-16 0,26 33 0,-1 0 0,-1-1 0,0 0 0,-27-28 0,10 17 0,3 9 0,0 4 0,-2-7 0,2-4 0,4 3 0,5 7 0,3 8 0,-1 2 0,-1-1 0,1-4 0,-2 0 0,0-1 0,2-1 0,-2-3 0,1-6 0,0-1 0,2 1 0,2 7 0,3 4 0,0 6 0,2 1 0,0 3 0,-4 1 0,0-2 0,-5-2 0,-1-2 0,0 3 0,1 0 0,-1 2 0,-2 1 0,-1-3 0,0 3 0,1 0 0,-4 0 0,-1 2 0,-1 1 0,7 2 0,8 4 0,1 3 0,-4 2 0,-6 0 0,-3 1 0,-1 1 0,1 2 0,1 2 0,1 3 0,1 0 0,6 3 0,7 0 0,11 0 0,5 0 0,-3 0 0,-7 2 0,-3 5 0,1 5 0,6 5 0,5 2 0,3 0 0,3-1 0,2-3 0,0 0 0,3 0 0,1 2 0,2 9 0,1 10 0,0 5 0,0 2 0,0-8 0,0-9 0,1-6 0,4-3 0,3-1 0,3-1 0,1-1 0,0-2 0,2-2 0,3-2 0,2 0 0,-1 1 0,-7-6 0,-4 3 0</inkml:trace>
+</inkml:ink>
 </file>
 
 <file path=ppt/slideLayouts/slideLayout1.xml><?xml version="1.0" encoding="utf-8"?>
@@ -3408,6 +3497,372 @@
           <a:chExt cx="0" cy="0"/>
         </a:xfrm>
       </p:grpSpPr>
+      <p:grpSp>
+        <p:nvGrpSpPr>
+          <p:cNvPr id="21" name="Group 20">
+            <a:extLst>
+              <a:ext uri="{FF2B5EF4-FFF2-40B4-BE49-F238E27FC236}">
+                <a16:creationId xmlns:a16="http://schemas.microsoft.com/office/drawing/2014/main" id="{F0DB74A2-B3EB-1BDC-A80F-87F55E6BBB96}"/>
+              </a:ext>
+            </a:extLst>
+          </p:cNvPr>
+          <p:cNvGrpSpPr/>
+          <p:nvPr/>
+        </p:nvGrpSpPr>
+        <p:grpSpPr>
+          <a:xfrm>
+            <a:off x="8617414" y="393490"/>
+            <a:ext cx="2893712" cy="3035509"/>
+            <a:chOff x="8655724" y="712031"/>
+            <a:chExt cx="2657929" cy="2788172"/>
+          </a:xfrm>
+        </p:grpSpPr>
+        <p:pic>
+          <p:nvPicPr>
+            <p:cNvPr id="5" name="Picture 4">
+              <a:extLst>
+                <a:ext uri="{FF2B5EF4-FFF2-40B4-BE49-F238E27FC236}">
+                  <a16:creationId xmlns:a16="http://schemas.microsoft.com/office/drawing/2014/main" id="{C9551752-B820-1218-E258-E9A2E979B9C0}"/>
+                </a:ext>
+              </a:extLst>
+            </p:cNvPr>
+            <p:cNvPicPr>
+              <a:picLocks noChangeAspect="1"/>
+            </p:cNvPicPr>
+            <p:nvPr/>
+          </p:nvPicPr>
+          <p:blipFill>
+            <a:blip r:embed="rId2"/>
+            <a:stretch>
+              <a:fillRect/>
+            </a:stretch>
+          </p:blipFill>
+          <p:spPr>
+            <a:xfrm>
+              <a:off x="8655724" y="712031"/>
+              <a:ext cx="2657929" cy="2788172"/>
+            </a:xfrm>
+            <a:prstGeom prst="rect">
+              <a:avLst/>
+            </a:prstGeom>
+          </p:spPr>
+        </p:pic>
+        <p:cxnSp>
+          <p:nvCxnSpPr>
+            <p:cNvPr id="8" name="Straight Connector 7">
+              <a:extLst>
+                <a:ext uri="{FF2B5EF4-FFF2-40B4-BE49-F238E27FC236}">
+                  <a16:creationId xmlns:a16="http://schemas.microsoft.com/office/drawing/2014/main" id="{19EDDB6C-BA67-3FD4-00D0-E280F50EADE0}"/>
+                </a:ext>
+              </a:extLst>
+            </p:cNvPr>
+            <p:cNvCxnSpPr>
+              <a:cxnSpLocks/>
+            </p:cNvCxnSpPr>
+            <p:nvPr/>
+          </p:nvCxnSpPr>
+          <p:spPr>
+            <a:xfrm>
+              <a:off x="8814216" y="831953"/>
+              <a:ext cx="2499437" cy="2480873"/>
+            </a:xfrm>
+            <a:prstGeom prst="line">
+              <a:avLst/>
+            </a:prstGeom>
+            <a:ln>
+              <a:solidFill>
+                <a:srgbClr val="FF0000"/>
+              </a:solidFill>
+            </a:ln>
+          </p:spPr>
+          <p:style>
+            <a:lnRef idx="2">
+              <a:schemeClr val="accent1"/>
+            </a:lnRef>
+            <a:fillRef idx="0">
+              <a:schemeClr val="accent1"/>
+            </a:fillRef>
+            <a:effectRef idx="1">
+              <a:schemeClr val="accent1"/>
+            </a:effectRef>
+            <a:fontRef idx="minor">
+              <a:schemeClr val="tx1"/>
+            </a:fontRef>
+          </p:style>
+        </p:cxnSp>
+      </p:grpSp>
+      <p:grpSp>
+        <p:nvGrpSpPr>
+          <p:cNvPr id="24" name="Group 23">
+            <a:extLst>
+              <a:ext uri="{FF2B5EF4-FFF2-40B4-BE49-F238E27FC236}">
+                <a16:creationId xmlns:a16="http://schemas.microsoft.com/office/drawing/2014/main" id="{9089F9EC-F3A4-95B8-5383-A4ABD1138A03}"/>
+              </a:ext>
+            </a:extLst>
+          </p:cNvPr>
+          <p:cNvGrpSpPr/>
+          <p:nvPr/>
+        </p:nvGrpSpPr>
+        <p:grpSpPr>
+          <a:xfrm>
+            <a:off x="8611588" y="3559559"/>
+            <a:ext cx="3077915" cy="3088158"/>
+            <a:chOff x="8689364" y="3972393"/>
+            <a:chExt cx="3077915" cy="3088158"/>
+          </a:xfrm>
+        </p:grpSpPr>
+        <p:pic>
+          <p:nvPicPr>
+            <p:cNvPr id="9" name="Picture 8">
+              <a:extLst>
+                <a:ext uri="{FF2B5EF4-FFF2-40B4-BE49-F238E27FC236}">
+                  <a16:creationId xmlns:a16="http://schemas.microsoft.com/office/drawing/2014/main" id="{4975DF10-DEEF-A04B-D88E-D47BB59EA0C1}"/>
+                </a:ext>
+              </a:extLst>
+            </p:cNvPr>
+            <p:cNvPicPr>
+              <a:picLocks noChangeAspect="1"/>
+            </p:cNvPicPr>
+            <p:nvPr/>
+          </p:nvPicPr>
+          <p:blipFill>
+            <a:blip r:embed="rId3"/>
+            <a:stretch>
+              <a:fillRect/>
+            </a:stretch>
+          </p:blipFill>
+          <p:spPr>
+            <a:xfrm>
+              <a:off x="8689364" y="3972393"/>
+              <a:ext cx="3077915" cy="3088158"/>
+            </a:xfrm>
+            <a:prstGeom prst="rect">
+              <a:avLst/>
+            </a:prstGeom>
+          </p:spPr>
+        </p:pic>
+        <p:cxnSp>
+          <p:nvCxnSpPr>
+            <p:cNvPr id="10" name="Straight Connector 9">
+              <a:extLst>
+                <a:ext uri="{FF2B5EF4-FFF2-40B4-BE49-F238E27FC236}">
+                  <a16:creationId xmlns:a16="http://schemas.microsoft.com/office/drawing/2014/main" id="{77AFE2CF-F901-A83E-D895-48262971D0C6}"/>
+                </a:ext>
+              </a:extLst>
+            </p:cNvPr>
+            <p:cNvCxnSpPr>
+              <a:cxnSpLocks/>
+            </p:cNvCxnSpPr>
+            <p:nvPr/>
+          </p:nvCxnSpPr>
+          <p:spPr>
+            <a:xfrm flipV="1">
+              <a:off x="8919148" y="4161402"/>
+              <a:ext cx="2683239" cy="2681608"/>
+            </a:xfrm>
+            <a:prstGeom prst="line">
+              <a:avLst/>
+            </a:prstGeom>
+            <a:ln>
+              <a:solidFill>
+                <a:srgbClr val="FF0000"/>
+              </a:solidFill>
+            </a:ln>
+          </p:spPr>
+          <p:style>
+            <a:lnRef idx="2">
+              <a:schemeClr val="accent1"/>
+            </a:lnRef>
+            <a:fillRef idx="0">
+              <a:schemeClr val="accent1"/>
+            </a:fillRef>
+            <a:effectRef idx="1">
+              <a:schemeClr val="accent1"/>
+            </a:effectRef>
+            <a:fontRef idx="minor">
+              <a:schemeClr val="tx1"/>
+            </a:fontRef>
+          </p:style>
+        </p:cxnSp>
+      </p:grpSp>
+      <p:pic>
+        <p:nvPicPr>
+          <p:cNvPr id="20" name="Picture 19">
+            <a:extLst>
+              <a:ext uri="{FF2B5EF4-FFF2-40B4-BE49-F238E27FC236}">
+                <a16:creationId xmlns:a16="http://schemas.microsoft.com/office/drawing/2014/main" id="{79B2EB48-EA6A-6715-183F-CE613819EE45}"/>
+              </a:ext>
+            </a:extLst>
+          </p:cNvPr>
+          <p:cNvPicPr>
+            <a:picLocks noChangeAspect="1"/>
+          </p:cNvPicPr>
+          <p:nvPr/>
+        </p:nvPicPr>
+        <p:blipFill>
+          <a:blip r:embed="rId4"/>
+          <a:stretch>
+            <a:fillRect/>
+          </a:stretch>
+        </p:blipFill>
+        <p:spPr>
+          <a:xfrm>
+            <a:off x="277590" y="393491"/>
+            <a:ext cx="6450093" cy="5838669"/>
+          </a:xfrm>
+          <a:prstGeom prst="rect">
+            <a:avLst/>
+          </a:prstGeom>
+        </p:spPr>
+      </p:pic>
+      <p:cxnSp>
+        <p:nvCxnSpPr>
+          <p:cNvPr id="26" name="Straight Arrow Connector 25">
+            <a:extLst>
+              <a:ext uri="{FF2B5EF4-FFF2-40B4-BE49-F238E27FC236}">
+                <a16:creationId xmlns:a16="http://schemas.microsoft.com/office/drawing/2014/main" id="{316AB98D-4B03-D4A4-B3BF-A0BEF2EE052B}"/>
+              </a:ext>
+            </a:extLst>
+          </p:cNvPr>
+          <p:cNvCxnSpPr>
+            <a:cxnSpLocks/>
+          </p:cNvCxnSpPr>
+          <p:nvPr/>
+        </p:nvCxnSpPr>
+        <p:spPr>
+          <a:xfrm flipH="1" flipV="1">
+            <a:off x="2983042" y="1664663"/>
+            <a:ext cx="5471410" cy="388989"/>
+          </a:xfrm>
+          <a:prstGeom prst="straightConnector1">
+            <a:avLst/>
+          </a:prstGeom>
+          <a:ln>
+            <a:solidFill>
+              <a:srgbClr val="FF0000"/>
+            </a:solidFill>
+            <a:tailEnd type="triangle"/>
+          </a:ln>
+        </p:spPr>
+        <p:style>
+          <a:lnRef idx="2">
+            <a:schemeClr val="accent1"/>
+          </a:lnRef>
+          <a:fillRef idx="0">
+            <a:schemeClr val="accent1"/>
+          </a:fillRef>
+          <a:effectRef idx="1">
+            <a:schemeClr val="accent1"/>
+          </a:effectRef>
+          <a:fontRef idx="minor">
+            <a:schemeClr val="tx1"/>
+          </a:fontRef>
+        </p:style>
+      </p:cxnSp>
+      <p:cxnSp>
+        <p:nvCxnSpPr>
+          <p:cNvPr id="28" name="Straight Arrow Connector 27">
+            <a:extLst>
+              <a:ext uri="{FF2B5EF4-FFF2-40B4-BE49-F238E27FC236}">
+                <a16:creationId xmlns:a16="http://schemas.microsoft.com/office/drawing/2014/main" id="{F95BE2EF-9D8A-C1FF-F84A-8CFB6895A60D}"/>
+              </a:ext>
+            </a:extLst>
+          </p:cNvPr>
+          <p:cNvCxnSpPr>
+            <a:cxnSpLocks/>
+          </p:cNvCxnSpPr>
+          <p:nvPr/>
+        </p:nvCxnSpPr>
+        <p:spPr>
+          <a:xfrm flipH="1">
+            <a:off x="4691921" y="2300233"/>
+            <a:ext cx="3839217" cy="1867033"/>
+          </a:xfrm>
+          <a:prstGeom prst="straightConnector1">
+            <a:avLst/>
+          </a:prstGeom>
+          <a:ln>
+            <a:solidFill>
+              <a:srgbClr val="FF0000"/>
+            </a:solidFill>
+            <a:tailEnd type="triangle"/>
+          </a:ln>
+        </p:spPr>
+        <p:style>
+          <a:lnRef idx="2">
+            <a:schemeClr val="accent1"/>
+          </a:lnRef>
+          <a:fillRef idx="0">
+            <a:schemeClr val="accent1"/>
+          </a:fillRef>
+          <a:effectRef idx="1">
+            <a:schemeClr val="accent1"/>
+          </a:effectRef>
+          <a:fontRef idx="minor">
+            <a:schemeClr val="tx1"/>
+          </a:fontRef>
+        </p:style>
+      </p:cxnSp>
+      <p:pic>
+        <p:nvPicPr>
+          <p:cNvPr id="30" name="Picture 29">
+            <a:extLst>
+              <a:ext uri="{FF2B5EF4-FFF2-40B4-BE49-F238E27FC236}">
+                <a16:creationId xmlns:a16="http://schemas.microsoft.com/office/drawing/2014/main" id="{E3074EE9-68E0-A998-D256-CD6AB2EC005E}"/>
+              </a:ext>
+            </a:extLst>
+          </p:cNvPr>
+          <p:cNvPicPr>
+            <a:picLocks noChangeAspect="1"/>
+          </p:cNvPicPr>
+          <p:nvPr/>
+        </p:nvPicPr>
+        <p:blipFill>
+          <a:blip r:embed="rId5"/>
+          <a:stretch>
+            <a:fillRect/>
+          </a:stretch>
+        </p:blipFill>
+        <p:spPr>
+          <a:xfrm>
+            <a:off x="6346403" y="393490"/>
+            <a:ext cx="2280601" cy="2286635"/>
+          </a:xfrm>
+          <a:prstGeom prst="rect">
+            <a:avLst/>
+          </a:prstGeom>
+        </p:spPr>
+      </p:pic>
+    </p:spTree>
+    <p:extLst>
+      <p:ext uri="{BB962C8B-B14F-4D97-AF65-F5344CB8AC3E}">
+        <p14:creationId xmlns:p14="http://schemas.microsoft.com/office/powerpoint/2010/main" val="3683574062"/>
+      </p:ext>
+    </p:extLst>
+  </p:cSld>
+  <p:clrMapOvr>
+    <a:masterClrMapping/>
+  </p:clrMapOvr>
+</p:sld>
+</file>
+
+<file path=ppt/slides/slide3.xml><?xml version="1.0" encoding="utf-8"?>
+<p:sld xmlns:a="http://schemas.openxmlformats.org/drawingml/2006/main" xmlns:r="http://schemas.openxmlformats.org/officeDocument/2006/relationships" xmlns:p="http://schemas.openxmlformats.org/presentationml/2006/main">
+  <p:cSld>
+    <p:spTree>
+      <p:nvGrpSpPr>
+        <p:cNvPr id="1" name=""/>
+        <p:cNvGrpSpPr/>
+        <p:nvPr/>
+      </p:nvGrpSpPr>
+      <p:grpSpPr>
+        <a:xfrm>
+          <a:off x="0" y="0"/>
+          <a:ext cx="0" cy="0"/>
+          <a:chOff x="0" y="0"/>
+          <a:chExt cx="0" cy="0"/>
+        </a:xfrm>
+      </p:grpSpPr>
       <p:sp>
         <p:nvSpPr>
           <p:cNvPr id="2" name="Title 1">
@@ -3436,7 +3891,7 @@
           <a:p>
             <a:r>
               <a:rPr lang="en-US" dirty="0"/>
-              <a:t>Ex3 Motif 6</a:t>
+              <a:t>Ex3 Motif 6 - RC</a:t>
             </a:r>
           </a:p>
         </p:txBody>
@@ -3459,8 +3914,8 @@
         </p:nvSpPr>
         <p:spPr>
           <a:xfrm>
-            <a:off x="893285" y="2725090"/>
-            <a:ext cx="4163458" cy="3837045"/>
+            <a:off x="299804" y="2725090"/>
+            <a:ext cx="5624320" cy="3837045"/>
           </a:xfrm>
         </p:spPr>
         <p:txBody>
@@ -3475,7 +3930,7 @@
           <a:p>
             <a:r>
               <a:rPr lang="en-US" dirty="0"/>
-              <a:t>[(22, 11), (23, 10), (24, 9), (25, 8)]</a:t>
+              <a:t>[(22, 11), (23, 10), (24, 9), (25, 8)]	</a:t>
             </a:r>
           </a:p>
           <a:p>
@@ -3545,6 +4000,189 @@
         </p:blipFill>
         <p:spPr>
           <a:xfrm>
+            <a:off x="3214" y="1008905"/>
+            <a:ext cx="5920910" cy="1577414"/>
+          </a:xfrm>
+          <a:prstGeom prst="rect">
+            <a:avLst/>
+          </a:prstGeom>
+        </p:spPr>
+      </p:pic>
+      <mc:AlternateContent xmlns:mc="http://schemas.openxmlformats.org/markup-compatibility/2006">
+        <mc:Choice xmlns:p14="http://schemas.microsoft.com/office/powerpoint/2010/main" Requires="p14">
+          <p:contentPart p14:bwMode="auto" r:id="rId4">
+            <p14:nvContentPartPr>
+              <p14:cNvPr id="10" name="Ink 9">
+                <a:extLst>
+                  <a:ext uri="{FF2B5EF4-FFF2-40B4-BE49-F238E27FC236}">
+                    <a16:creationId xmlns:a16="http://schemas.microsoft.com/office/drawing/2014/main" id="{6200709B-4E6B-A846-BF80-E7503E052B7D}"/>
+                  </a:ext>
+                </a:extLst>
+              </p14:cNvPr>
+              <p14:cNvContentPartPr/>
+              <p14:nvPr/>
+            </p14:nvContentPartPr>
+            <p14:xfrm>
+              <a:off x="8081760" y="5434029"/>
+              <a:ext cx="971280" cy="936000"/>
+            </p14:xfrm>
+          </p:contentPart>
+        </mc:Choice>
+        <mc:Fallback>
+          <p:pic>
+            <p:nvPicPr>
+              <p:cNvPr id="10" name="Ink 9">
+                <a:extLst>
+                  <a:ext uri="{FF2B5EF4-FFF2-40B4-BE49-F238E27FC236}">
+                    <a16:creationId xmlns:a16="http://schemas.microsoft.com/office/drawing/2014/main" id="{6200709B-4E6B-A846-BF80-E7503E052B7D}"/>
+                  </a:ext>
+                </a:extLst>
+              </p:cNvPr>
+              <p:cNvPicPr/>
+              <p:nvPr/>
+            </p:nvPicPr>
+            <p:blipFill>
+              <a:blip r:embed="rId5"/>
+              <a:stretch>
+                <a:fillRect/>
+              </a:stretch>
+            </p:blipFill>
+            <p:spPr>
+              <a:xfrm>
+                <a:off x="8075640" y="5427909"/>
+                <a:ext cx="983520" cy="948240"/>
+              </a:xfrm>
+              <a:prstGeom prst="rect">
+                <a:avLst/>
+              </a:prstGeom>
+            </p:spPr>
+          </p:pic>
+        </mc:Fallback>
+      </mc:AlternateContent>
+    </p:spTree>
+    <p:extLst>
+      <p:ext uri="{BB962C8B-B14F-4D97-AF65-F5344CB8AC3E}">
+        <p14:creationId xmlns:p14="http://schemas.microsoft.com/office/powerpoint/2010/main" val="2806744044"/>
+      </p:ext>
+    </p:extLst>
+  </p:cSld>
+  <p:clrMapOvr>
+    <a:masterClrMapping/>
+  </p:clrMapOvr>
+</p:sld>
+</file>
+
+<file path=ppt/slides/slide4.xml><?xml version="1.0" encoding="utf-8"?>
+<p:sld xmlns:a="http://schemas.openxmlformats.org/drawingml/2006/main" xmlns:r="http://schemas.openxmlformats.org/officeDocument/2006/relationships" xmlns:p="http://schemas.openxmlformats.org/presentationml/2006/main">
+  <p:cSld>
+    <p:spTree>
+      <p:nvGrpSpPr>
+        <p:cNvPr id="1" name="">
+          <a:extLst>
+            <a:ext uri="{FF2B5EF4-FFF2-40B4-BE49-F238E27FC236}">
+              <a16:creationId xmlns:a16="http://schemas.microsoft.com/office/drawing/2014/main" id="{ECD04A04-76B5-813A-EE63-D8BEEF0BE2EB}"/>
+            </a:ext>
+          </a:extLst>
+        </p:cNvPr>
+        <p:cNvGrpSpPr/>
+        <p:nvPr/>
+      </p:nvGrpSpPr>
+      <p:grpSpPr>
+        <a:xfrm>
+          <a:off x="0" y="0"/>
+          <a:ext cx="0" cy="0"/>
+          <a:chOff x="0" y="0"/>
+          <a:chExt cx="0" cy="0"/>
+        </a:xfrm>
+      </p:grpSpPr>
+      <p:sp>
+        <p:nvSpPr>
+          <p:cNvPr id="2" name="Title 1">
+            <a:extLst>
+              <a:ext uri="{FF2B5EF4-FFF2-40B4-BE49-F238E27FC236}">
+                <a16:creationId xmlns:a16="http://schemas.microsoft.com/office/drawing/2014/main" id="{7BE58909-61F0-A914-D980-E27E450EEC24}"/>
+              </a:ext>
+            </a:extLst>
+          </p:cNvPr>
+          <p:cNvSpPr>
+            <a:spLocks noGrp="1"/>
+          </p:cNvSpPr>
+          <p:nvPr>
+            <p:ph type="title"/>
+          </p:nvPr>
+        </p:nvSpPr>
+        <p:spPr>
+          <a:xfrm>
+            <a:off x="518711" y="73964"/>
+            <a:ext cx="10515600" cy="1325563"/>
+          </a:xfrm>
+        </p:spPr>
+        <p:txBody>
+          <a:bodyPr/>
+          <a:lstStyle/>
+          <a:p>
+            <a:r>
+              <a:rPr lang="en-US" dirty="0"/>
+              <a:t>Ex3 Motif 6 - Direct</a:t>
+            </a:r>
+          </a:p>
+        </p:txBody>
+      </p:sp>
+      <p:sp>
+        <p:nvSpPr>
+          <p:cNvPr id="3" name="Content Placeholder 2">
+            <a:extLst>
+              <a:ext uri="{FF2B5EF4-FFF2-40B4-BE49-F238E27FC236}">
+                <a16:creationId xmlns:a16="http://schemas.microsoft.com/office/drawing/2014/main" id="{73FA7CDD-6116-DB91-2D59-B78CD6B72E8F}"/>
+              </a:ext>
+            </a:extLst>
+          </p:cNvPr>
+          <p:cNvSpPr>
+            <a:spLocks noGrp="1"/>
+          </p:cNvSpPr>
+          <p:nvPr>
+            <p:ph idx="1"/>
+          </p:nvPr>
+        </p:nvSpPr>
+        <p:spPr>
+          <a:xfrm>
+            <a:off x="299804" y="2725091"/>
+            <a:ext cx="5624320" cy="2047326"/>
+          </a:xfrm>
+        </p:spPr>
+        <p:txBody>
+          <a:bodyPr/>
+          <a:lstStyle/>
+          <a:p>
+            <a:r>
+              <a:rPr lang="en-US" dirty="0"/>
+              <a:t>TTCC..TTCC</a:t>
+            </a:r>
+          </a:p>
+        </p:txBody>
+      </p:sp>
+      <p:pic>
+        <p:nvPicPr>
+          <p:cNvPr id="9" name="Picture 8" descr="A colorful text on a black background&#10;&#10;AI-generated content may be incorrect.">
+            <a:extLst>
+              <a:ext uri="{FF2B5EF4-FFF2-40B4-BE49-F238E27FC236}">
+                <a16:creationId xmlns:a16="http://schemas.microsoft.com/office/drawing/2014/main" id="{0B9E1147-A61E-252F-EFA7-0E053FE9E20F}"/>
+              </a:ext>
+            </a:extLst>
+          </p:cNvPr>
+          <p:cNvPicPr>
+            <a:picLocks noChangeAspect="1"/>
+          </p:cNvPicPr>
+          <p:nvPr/>
+        </p:nvPicPr>
+        <p:blipFill>
+          <a:blip r:embed="rId2"/>
+          <a:stretch>
+            <a:fillRect/>
+          </a:stretch>
+        </p:blipFill>
+        <p:spPr>
+          <a:xfrm>
             <a:off x="3214" y="995458"/>
             <a:ext cx="5920910" cy="1577414"/>
           </a:xfrm>
@@ -3556,7 +4194,558 @@
     </p:spTree>
     <p:extLst>
       <p:ext uri="{BB962C8B-B14F-4D97-AF65-F5344CB8AC3E}">
-        <p14:creationId xmlns:p14="http://schemas.microsoft.com/office/powerpoint/2010/main" val="2806744044"/>
+        <p14:creationId xmlns:p14="http://schemas.microsoft.com/office/powerpoint/2010/main" val="1462279627"/>
+      </p:ext>
+    </p:extLst>
+  </p:cSld>
+  <p:clrMapOvr>
+    <a:masterClrMapping/>
+  </p:clrMapOvr>
+</p:sld>
+</file>
+
+<file path=ppt/slides/slide5.xml><?xml version="1.0" encoding="utf-8"?>
+<p:sld xmlns:a="http://schemas.openxmlformats.org/drawingml/2006/main" xmlns:r="http://schemas.openxmlformats.org/officeDocument/2006/relationships" xmlns:p="http://schemas.openxmlformats.org/presentationml/2006/main">
+  <p:cSld>
+    <p:spTree>
+      <p:nvGrpSpPr>
+        <p:cNvPr id="1" name=""/>
+        <p:cNvGrpSpPr/>
+        <p:nvPr/>
+      </p:nvGrpSpPr>
+      <p:grpSpPr>
+        <a:xfrm>
+          <a:off x="0" y="0"/>
+          <a:ext cx="0" cy="0"/>
+          <a:chOff x="0" y="0"/>
+          <a:chExt cx="0" cy="0"/>
+        </a:xfrm>
+      </p:grpSpPr>
+      <p:sp>
+        <p:nvSpPr>
+          <p:cNvPr id="2" name="Title 1">
+            <a:extLst>
+              <a:ext uri="{FF2B5EF4-FFF2-40B4-BE49-F238E27FC236}">
+                <a16:creationId xmlns:a16="http://schemas.microsoft.com/office/drawing/2014/main" id="{66522F35-878E-ABC7-435F-A49ABA5D0752}"/>
+              </a:ext>
+            </a:extLst>
+          </p:cNvPr>
+          <p:cNvSpPr>
+            <a:spLocks noGrp="1"/>
+          </p:cNvSpPr>
+          <p:nvPr>
+            <p:ph type="title"/>
+          </p:nvPr>
+        </p:nvSpPr>
+        <p:spPr/>
+        <p:txBody>
+          <a:bodyPr/>
+          <a:lstStyle/>
+          <a:p>
+            <a:r>
+              <a:rPr lang="en-US" dirty="0"/>
+              <a:t>Thresholding </a:t>
+            </a:r>
+          </a:p>
+        </p:txBody>
+      </p:sp>
+      <p:pic>
+        <p:nvPicPr>
+          <p:cNvPr id="4" name="Picture 3">
+            <a:extLst>
+              <a:ext uri="{FF2B5EF4-FFF2-40B4-BE49-F238E27FC236}">
+                <a16:creationId xmlns:a16="http://schemas.microsoft.com/office/drawing/2014/main" id="{760E9753-41F1-F955-0FD3-DB345038F7BD}"/>
+              </a:ext>
+            </a:extLst>
+          </p:cNvPr>
+          <p:cNvPicPr>
+            <a:picLocks noChangeAspect="1"/>
+          </p:cNvPicPr>
+          <p:nvPr/>
+        </p:nvPicPr>
+        <p:blipFill>
+          <a:blip r:embed="rId2"/>
+          <a:stretch>
+            <a:fillRect/>
+          </a:stretch>
+        </p:blipFill>
+        <p:spPr>
+          <a:xfrm>
+            <a:off x="838200" y="1573494"/>
+            <a:ext cx="7435850" cy="5094533"/>
+          </a:xfrm>
+          <a:prstGeom prst="rect">
+            <a:avLst/>
+          </a:prstGeom>
+        </p:spPr>
+      </p:pic>
+    </p:spTree>
+    <p:extLst>
+      <p:ext uri="{BB962C8B-B14F-4D97-AF65-F5344CB8AC3E}">
+        <p14:creationId xmlns:p14="http://schemas.microsoft.com/office/powerpoint/2010/main" val="2729002016"/>
+      </p:ext>
+    </p:extLst>
+  </p:cSld>
+  <p:clrMapOvr>
+    <a:masterClrMapping/>
+  </p:clrMapOvr>
+</p:sld>
+</file>
+
+<file path=ppt/slides/slide6.xml><?xml version="1.0" encoding="utf-8"?>
+<p:sld xmlns:a="http://schemas.openxmlformats.org/drawingml/2006/main" xmlns:r="http://schemas.openxmlformats.org/officeDocument/2006/relationships" xmlns:p="http://schemas.openxmlformats.org/presentationml/2006/main">
+  <p:cSld>
+    <p:spTree>
+      <p:nvGrpSpPr>
+        <p:cNvPr id="1" name="">
+          <a:extLst>
+            <a:ext uri="{FF2B5EF4-FFF2-40B4-BE49-F238E27FC236}">
+              <a16:creationId xmlns:a16="http://schemas.microsoft.com/office/drawing/2014/main" id="{329C5157-9462-FF6D-599A-46C21F9765BD}"/>
+            </a:ext>
+          </a:extLst>
+        </p:cNvPr>
+        <p:cNvGrpSpPr/>
+        <p:nvPr/>
+      </p:nvGrpSpPr>
+      <p:grpSpPr>
+        <a:xfrm>
+          <a:off x="0" y="0"/>
+          <a:ext cx="0" cy="0"/>
+          <a:chOff x="0" y="0"/>
+          <a:chExt cx="0" cy="0"/>
+        </a:xfrm>
+      </p:grpSpPr>
+      <p:sp>
+        <p:nvSpPr>
+          <p:cNvPr id="2" name="Title 1">
+            <a:extLst>
+              <a:ext uri="{FF2B5EF4-FFF2-40B4-BE49-F238E27FC236}">
+                <a16:creationId xmlns:a16="http://schemas.microsoft.com/office/drawing/2014/main" id="{3D6A5CE9-C708-F5FC-CF87-281EAA0AD5A6}"/>
+              </a:ext>
+            </a:extLst>
+          </p:cNvPr>
+          <p:cNvSpPr>
+            <a:spLocks noGrp="1"/>
+          </p:cNvSpPr>
+          <p:nvPr>
+            <p:ph type="title"/>
+          </p:nvPr>
+        </p:nvSpPr>
+        <p:spPr>
+          <a:xfrm>
+            <a:off x="518711" y="73964"/>
+            <a:ext cx="10515600" cy="1325563"/>
+          </a:xfrm>
+        </p:spPr>
+        <p:txBody>
+          <a:bodyPr/>
+          <a:lstStyle/>
+          <a:p>
+            <a:r>
+              <a:rPr lang="en-US" dirty="0"/>
+              <a:t>Ex3 Motif 4 - RC</a:t>
+            </a:r>
+          </a:p>
+        </p:txBody>
+      </p:sp>
+      <p:sp>
+        <p:nvSpPr>
+          <p:cNvPr id="3" name="Content Placeholder 2">
+            <a:extLst>
+              <a:ext uri="{FF2B5EF4-FFF2-40B4-BE49-F238E27FC236}">
+                <a16:creationId xmlns:a16="http://schemas.microsoft.com/office/drawing/2014/main" id="{A5FE17FE-E768-23D7-AE4F-70A1F9E2BD95}"/>
+              </a:ext>
+            </a:extLst>
+          </p:cNvPr>
+          <p:cNvSpPr>
+            <a:spLocks noGrp="1"/>
+          </p:cNvSpPr>
+          <p:nvPr>
+            <p:ph idx="1"/>
+          </p:nvPr>
+        </p:nvSpPr>
+        <p:spPr>
+          <a:xfrm>
+            <a:off x="299804" y="2725090"/>
+            <a:ext cx="5624320" cy="3837045"/>
+          </a:xfrm>
+        </p:spPr>
+        <p:txBody>
+          <a:bodyPr/>
+          <a:lstStyle/>
+          <a:p>
+            <a:r>
+              <a:rPr lang="en-US" dirty="0"/>
+              <a:t>GCACCA…TGGTGC</a:t>
+            </a:r>
+          </a:p>
+          <a:p>
+            <a:r>
+              <a:rPr lang="en-US" dirty="0"/>
+              <a:t>[(14, 6), (15, 5), (16, 4), (17, 3)]</a:t>
+            </a:r>
+          </a:p>
+          <a:p>
+            <a:r>
+              <a:rPr lang="en-US" dirty="0"/>
+              <a:t>Sum IC-JSD: 5.79</a:t>
+            </a:r>
+          </a:p>
+          <a:p>
+            <a:endParaRPr lang="en-US" dirty="0"/>
+          </a:p>
+        </p:txBody>
+      </p:sp>
+      <p:pic>
+        <p:nvPicPr>
+          <p:cNvPr id="6" name="Picture 5" descr="A colorful text on a black background&#10;&#10;AI-generated content may be incorrect.">
+            <a:extLst>
+              <a:ext uri="{FF2B5EF4-FFF2-40B4-BE49-F238E27FC236}">
+                <a16:creationId xmlns:a16="http://schemas.microsoft.com/office/drawing/2014/main" id="{84E8170A-A5B8-33AF-8A4B-B49132025521}"/>
+              </a:ext>
+            </a:extLst>
+          </p:cNvPr>
+          <p:cNvPicPr>
+            <a:picLocks noChangeAspect="1"/>
+          </p:cNvPicPr>
+          <p:nvPr/>
+        </p:nvPicPr>
+        <p:blipFill>
+          <a:blip r:embed="rId2"/>
+          <a:stretch>
+            <a:fillRect/>
+          </a:stretch>
+        </p:blipFill>
+        <p:spPr>
+          <a:xfrm>
+            <a:off x="62866" y="643061"/>
+            <a:ext cx="5861258" cy="2082029"/>
+          </a:xfrm>
+          <a:prstGeom prst="rect">
+            <a:avLst/>
+          </a:prstGeom>
+        </p:spPr>
+      </p:pic>
+      <p:pic>
+        <p:nvPicPr>
+          <p:cNvPr id="11" name="Picture 10">
+            <a:extLst>
+              <a:ext uri="{FF2B5EF4-FFF2-40B4-BE49-F238E27FC236}">
+                <a16:creationId xmlns:a16="http://schemas.microsoft.com/office/drawing/2014/main" id="{DF7F282B-2E0B-720A-8D90-6B123B2D99DB}"/>
+              </a:ext>
+            </a:extLst>
+          </p:cNvPr>
+          <p:cNvPicPr>
+            <a:picLocks noChangeAspect="1"/>
+          </p:cNvPicPr>
+          <p:nvPr/>
+        </p:nvPicPr>
+        <p:blipFill>
+          <a:blip r:embed="rId3"/>
+          <a:srcRect r="14596"/>
+          <a:stretch>
+            <a:fillRect/>
+          </a:stretch>
+        </p:blipFill>
+        <p:spPr>
+          <a:xfrm>
+            <a:off x="5924124" y="295865"/>
+            <a:ext cx="6054979" cy="6266270"/>
+          </a:xfrm>
+          <a:prstGeom prst="rect">
+            <a:avLst/>
+          </a:prstGeom>
+        </p:spPr>
+      </p:pic>
+      <mc:AlternateContent xmlns:mc="http://schemas.openxmlformats.org/markup-compatibility/2006">
+        <mc:Choice xmlns:p14="http://schemas.microsoft.com/office/powerpoint/2010/main" Requires="p14">
+          <p:contentPart p14:bwMode="auto" r:id="rId4">
+            <p14:nvContentPartPr>
+              <p14:cNvPr id="12" name="Ink 11">
+                <a:extLst>
+                  <a:ext uri="{FF2B5EF4-FFF2-40B4-BE49-F238E27FC236}">
+                    <a16:creationId xmlns:a16="http://schemas.microsoft.com/office/drawing/2014/main" id="{51164F29-87BF-3DC8-EED6-65CFA7131CE9}"/>
+                  </a:ext>
+                </a:extLst>
+              </p14:cNvPr>
+              <p14:cNvContentPartPr/>
+              <p14:nvPr/>
+            </p14:nvContentPartPr>
+            <p14:xfrm>
+              <a:off x="7196351" y="4630262"/>
+              <a:ext cx="1230480" cy="1218600"/>
+            </p14:xfrm>
+          </p:contentPart>
+        </mc:Choice>
+        <mc:Fallback>
+          <p:pic>
+            <p:nvPicPr>
+              <p:cNvPr id="12" name="Ink 11">
+                <a:extLst>
+                  <a:ext uri="{FF2B5EF4-FFF2-40B4-BE49-F238E27FC236}">
+                    <a16:creationId xmlns:a16="http://schemas.microsoft.com/office/drawing/2014/main" id="{51164F29-87BF-3DC8-EED6-65CFA7131CE9}"/>
+                  </a:ext>
+                </a:extLst>
+              </p:cNvPr>
+              <p:cNvPicPr/>
+              <p:nvPr/>
+            </p:nvPicPr>
+            <p:blipFill>
+              <a:blip r:embed="rId5"/>
+              <a:stretch>
+                <a:fillRect/>
+              </a:stretch>
+            </p:blipFill>
+            <p:spPr>
+              <a:xfrm>
+                <a:off x="7190231" y="4624142"/>
+                <a:ext cx="1242720" cy="1230840"/>
+              </a:xfrm>
+              <a:prstGeom prst="rect">
+                <a:avLst/>
+              </a:prstGeom>
+            </p:spPr>
+          </p:pic>
+        </mc:Fallback>
+      </mc:AlternateContent>
+    </p:spTree>
+    <p:extLst>
+      <p:ext uri="{BB962C8B-B14F-4D97-AF65-F5344CB8AC3E}">
+        <p14:creationId xmlns:p14="http://schemas.microsoft.com/office/powerpoint/2010/main" val="2383814175"/>
+      </p:ext>
+    </p:extLst>
+  </p:cSld>
+  <p:clrMapOvr>
+    <a:masterClrMapping/>
+  </p:clrMapOvr>
+</p:sld>
+</file>
+
+<file path=ppt/slides/slide7.xml><?xml version="1.0" encoding="utf-8"?>
+<p:sld xmlns:a="http://schemas.openxmlformats.org/drawingml/2006/main" xmlns:r="http://schemas.openxmlformats.org/officeDocument/2006/relationships" xmlns:p="http://schemas.openxmlformats.org/presentationml/2006/main">
+  <p:cSld>
+    <p:spTree>
+      <p:nvGrpSpPr>
+        <p:cNvPr id="1" name="">
+          <a:extLst>
+            <a:ext uri="{FF2B5EF4-FFF2-40B4-BE49-F238E27FC236}">
+              <a16:creationId xmlns:a16="http://schemas.microsoft.com/office/drawing/2014/main" id="{2B204A22-393E-09C6-62D7-C9E93686C32D}"/>
+            </a:ext>
+          </a:extLst>
+        </p:cNvPr>
+        <p:cNvGrpSpPr/>
+        <p:nvPr/>
+      </p:nvGrpSpPr>
+      <p:grpSpPr>
+        <a:xfrm>
+          <a:off x="0" y="0"/>
+          <a:ext cx="0" cy="0"/>
+          <a:chOff x="0" y="0"/>
+          <a:chExt cx="0" cy="0"/>
+        </a:xfrm>
+      </p:grpSpPr>
+      <p:sp>
+        <p:nvSpPr>
+          <p:cNvPr id="2" name="Title 1">
+            <a:extLst>
+              <a:ext uri="{FF2B5EF4-FFF2-40B4-BE49-F238E27FC236}">
+                <a16:creationId xmlns:a16="http://schemas.microsoft.com/office/drawing/2014/main" id="{0C838CA3-AD92-DA54-DA65-B42FE369D400}"/>
+              </a:ext>
+            </a:extLst>
+          </p:cNvPr>
+          <p:cNvSpPr>
+            <a:spLocks noGrp="1"/>
+          </p:cNvSpPr>
+          <p:nvPr>
+            <p:ph type="title"/>
+          </p:nvPr>
+        </p:nvSpPr>
+        <p:spPr>
+          <a:xfrm>
+            <a:off x="518711" y="73964"/>
+            <a:ext cx="10515600" cy="1325563"/>
+          </a:xfrm>
+        </p:spPr>
+        <p:txBody>
+          <a:bodyPr/>
+          <a:lstStyle/>
+          <a:p>
+            <a:r>
+              <a:rPr lang="en-US" dirty="0"/>
+              <a:t>Ex3 Motif 4 - Direct</a:t>
+            </a:r>
+          </a:p>
+        </p:txBody>
+      </p:sp>
+      <p:sp>
+        <p:nvSpPr>
+          <p:cNvPr id="3" name="Content Placeholder 2">
+            <a:extLst>
+              <a:ext uri="{FF2B5EF4-FFF2-40B4-BE49-F238E27FC236}">
+                <a16:creationId xmlns:a16="http://schemas.microsoft.com/office/drawing/2014/main" id="{BB32FE38-F86B-21FD-8FCD-7A0377132CCA}"/>
+              </a:ext>
+            </a:extLst>
+          </p:cNvPr>
+          <p:cNvSpPr>
+            <a:spLocks noGrp="1"/>
+          </p:cNvSpPr>
+          <p:nvPr>
+            <p:ph idx="1"/>
+          </p:nvPr>
+        </p:nvSpPr>
+        <p:spPr>
+          <a:xfrm>
+            <a:off x="299804" y="2725091"/>
+            <a:ext cx="5624320" cy="2047326"/>
+          </a:xfrm>
+        </p:spPr>
+        <p:txBody>
+          <a:bodyPr>
+            <a:normAutofit/>
+          </a:bodyPr>
+          <a:lstStyle/>
+          <a:p>
+            <a:pPr marL="0" indent="0">
+              <a:buNone/>
+            </a:pPr>
+            <a:endParaRPr lang="en-US" dirty="0"/>
+          </a:p>
+          <a:p>
+            <a:r>
+              <a:rPr lang="en-US" dirty="0"/>
+              <a:t>AAAA</a:t>
+            </a:r>
+          </a:p>
+          <a:p>
+            <a:r>
+              <a:rPr lang="en-US" dirty="0"/>
+              <a:t>[(14, 4), (15, 5), (16, 6)]</a:t>
+            </a:r>
+          </a:p>
+          <a:p>
+            <a:r>
+              <a:rPr lang="en-US" dirty="0"/>
+              <a:t>8.065600973930767</a:t>
+            </a:r>
+          </a:p>
+        </p:txBody>
+      </p:sp>
+      <p:pic>
+        <p:nvPicPr>
+          <p:cNvPr id="6" name="Picture 5" descr="A colorful text on a black background&#10;&#10;AI-generated content may be incorrect.">
+            <a:extLst>
+              <a:ext uri="{FF2B5EF4-FFF2-40B4-BE49-F238E27FC236}">
+                <a16:creationId xmlns:a16="http://schemas.microsoft.com/office/drawing/2014/main" id="{5FEA4018-CD2C-CD7C-D902-4F17182B04F3}"/>
+              </a:ext>
+            </a:extLst>
+          </p:cNvPr>
+          <p:cNvPicPr>
+            <a:picLocks noChangeAspect="1"/>
+          </p:cNvPicPr>
+          <p:nvPr/>
+        </p:nvPicPr>
+        <p:blipFill>
+          <a:blip r:embed="rId2"/>
+          <a:stretch>
+            <a:fillRect/>
+          </a:stretch>
+        </p:blipFill>
+        <p:spPr>
+          <a:xfrm>
+            <a:off x="62866" y="834758"/>
+            <a:ext cx="5861258" cy="2082029"/>
+          </a:xfrm>
+          <a:prstGeom prst="rect">
+            <a:avLst/>
+          </a:prstGeom>
+        </p:spPr>
+      </p:pic>
+      <p:pic>
+        <p:nvPicPr>
+          <p:cNvPr id="7" name="Picture 6">
+            <a:extLst>
+              <a:ext uri="{FF2B5EF4-FFF2-40B4-BE49-F238E27FC236}">
+                <a16:creationId xmlns:a16="http://schemas.microsoft.com/office/drawing/2014/main" id="{57A5F7F1-E09F-8E74-7469-FA79585D43BE}"/>
+              </a:ext>
+            </a:extLst>
+          </p:cNvPr>
+          <p:cNvPicPr>
+            <a:picLocks noChangeAspect="1"/>
+          </p:cNvPicPr>
+          <p:nvPr/>
+        </p:nvPicPr>
+        <p:blipFill>
+          <a:blip r:embed="rId3"/>
+          <a:srcRect r="14596"/>
+          <a:stretch>
+            <a:fillRect/>
+          </a:stretch>
+        </p:blipFill>
+        <p:spPr>
+          <a:xfrm>
+            <a:off x="5924124" y="295865"/>
+            <a:ext cx="6054979" cy="6266270"/>
+          </a:xfrm>
+          <a:prstGeom prst="rect">
+            <a:avLst/>
+          </a:prstGeom>
+        </p:spPr>
+      </p:pic>
+      <mc:AlternateContent xmlns:mc="http://schemas.openxmlformats.org/markup-compatibility/2006">
+        <mc:Choice xmlns:p14="http://schemas.microsoft.com/office/powerpoint/2010/main" Requires="p14">
+          <p:contentPart p14:bwMode="auto" r:id="rId4">
+            <p14:nvContentPartPr>
+              <p14:cNvPr id="10" name="Ink 9">
+                <a:extLst>
+                  <a:ext uri="{FF2B5EF4-FFF2-40B4-BE49-F238E27FC236}">
+                    <a16:creationId xmlns:a16="http://schemas.microsoft.com/office/drawing/2014/main" id="{8E70F423-179E-E237-C143-CC2B7B30A245}"/>
+                  </a:ext>
+                </a:extLst>
+              </p14:cNvPr>
+              <p14:cNvContentPartPr/>
+              <p14:nvPr/>
+            </p14:nvContentPartPr>
+            <p14:xfrm>
+              <a:off x="7539071" y="4647182"/>
+              <a:ext cx="978840" cy="916920"/>
+            </p14:xfrm>
+          </p:contentPart>
+        </mc:Choice>
+        <mc:Fallback>
+          <p:pic>
+            <p:nvPicPr>
+              <p:cNvPr id="10" name="Ink 9">
+                <a:extLst>
+                  <a:ext uri="{FF2B5EF4-FFF2-40B4-BE49-F238E27FC236}">
+                    <a16:creationId xmlns:a16="http://schemas.microsoft.com/office/drawing/2014/main" id="{8E70F423-179E-E237-C143-CC2B7B30A245}"/>
+                  </a:ext>
+                </a:extLst>
+              </p:cNvPr>
+              <p:cNvPicPr/>
+              <p:nvPr/>
+            </p:nvPicPr>
+            <p:blipFill>
+              <a:blip r:embed="rId5"/>
+              <a:stretch>
+                <a:fillRect/>
+              </a:stretch>
+            </p:blipFill>
+            <p:spPr>
+              <a:xfrm>
+                <a:off x="7532951" y="4641062"/>
+                <a:ext cx="991080" cy="929160"/>
+              </a:xfrm>
+              <a:prstGeom prst="rect">
+                <a:avLst/>
+              </a:prstGeom>
+            </p:spPr>
+          </p:pic>
+        </mc:Fallback>
+      </mc:AlternateContent>
+    </p:spTree>
+    <p:extLst>
+      <p:ext uri="{BB962C8B-B14F-4D97-AF65-F5344CB8AC3E}">
+        <p14:creationId xmlns:p14="http://schemas.microsoft.com/office/powerpoint/2010/main" val="2258113101"/>
       </p:ext>
     </p:extLst>
   </p:cSld>

</xml_diff>